<commit_message>
Slide 8: "1 標準偏差あたり" throughout (the return and volatility cells and the footnote)
Co-Authored-By: Claude Opus 5.5 <noreply@anthropic.com>
</commit_message>
<xml_diff>
--- a/資料集/08_発表/2026_情報工学工房発表資料.pptx
+++ b/資料集/08_発表/2026_情報工学工房発表資料.pptx
@@ -29652,7 +29652,7 @@
                 <a:ea typeface="メイリオ"/>
                 <a:cs typeface="メイリオ"/>
               </a:rPr>
-              <a:t>*1: 1SD あたり＝点数が 1 標準偏差高い発表ほど、発表後リターン（変動率）がどれだけ高いか。BLM は片道 0.3% の費用を控除（2017-01〜2026-09）、ありえない日次リターンを除いた探索的な計算</a:t>
+              <a:t>*1: 1 標準偏差あたり＝点数が 1 標準偏差高い発表ほど、発表後リターン（変動率）がどれだけ高いか。BLM は片道 0.3% の費用を控除（2017-01〜2026-09）、ありえない日次リターンを除いた探索的な計算</a:t>
             </a:r>
           </a:p>
         </p:txBody>
@@ -30189,29 +30189,7 @@
                 <a:ea typeface="メイリオ"/>
                 <a:cs typeface="メイリオ"/>
               </a:rPr>
-              <a:t>点数 1</a:t>
-            </a:r>
-            <a:r>
-              <a:rPr lang="ja-JP" altLang="en-US" sz="1000" b="0" dirty="0">
-                <a:solidFill>
-                  <a:srgbClr val="7E7F7E"/>
-                </a:solidFill>
-                <a:latin typeface="メイリオ"/>
-                <a:ea typeface="メイリオ"/>
-                <a:cs typeface="メイリオ"/>
-              </a:rPr>
-              <a:t>標準偏差</a:t>
-            </a:r>
-            <a:r>
-              <a:rPr lang="ja-JP" sz="1000" b="0" dirty="0">
-                <a:solidFill>
-                  <a:srgbClr val="7E7F7E"/>
-                </a:solidFill>
-                <a:latin typeface="メイリオ"/>
-                <a:ea typeface="メイリオ"/>
-                <a:cs typeface="メイリオ"/>
-              </a:rPr>
-              <a:t> あたり +0.76%</a:t>
+              <a:t>1 標準偏差あたり +0.76%</a:t>
             </a:r>
           </a:p>
         </p:txBody>
@@ -30307,29 +30285,7 @@
                 <a:ea typeface="メイリオ"/>
                 <a:cs typeface="メイリオ"/>
               </a:rPr>
-              <a:t>点数 1</a:t>
-            </a:r>
-            <a:r>
-              <a:rPr lang="ja-JP" altLang="en-US" sz="1000" dirty="0">
-                <a:solidFill>
-                  <a:srgbClr val="7E7F7E"/>
-                </a:solidFill>
-                <a:latin typeface="メイリオ"/>
-                <a:ea typeface="メイリオ"/>
-                <a:cs typeface="メイリオ"/>
-              </a:rPr>
-              <a:t>標準偏差</a:t>
-            </a:r>
-            <a:r>
-              <a:rPr lang="ja-JP" sz="1000" b="0" dirty="0">
-                <a:solidFill>
-                  <a:srgbClr val="7E7F7E"/>
-                </a:solidFill>
-                <a:latin typeface="メイリオ"/>
-                <a:ea typeface="メイリオ"/>
-                <a:cs typeface="メイリオ"/>
-              </a:rPr>
-              <a:t>あたり +0.54%</a:t>
+              <a:t>1 標準偏差あたり +0.54%</a:t>
             </a:r>
           </a:p>
         </p:txBody>
@@ -30521,7 +30477,21 @@
                 <a:ea typeface="メイリオ"/>
                 <a:cs typeface="メイリオ"/>
               </a:rPr>
-              <a:t>1SD あたり 1.5% 増し</a:t>
+              <a:t>1 標準偏差あたり</a:t>
+            </a:r>
+          </a:p>
+          <a:p>
+            <a:pPr algn="ctr"/>
+            <a:r>
+              <a:rPr lang="ja-JP" sz="1000" b="0" dirty="0">
+                <a:solidFill>
+                  <a:srgbClr val="7E7F7E"/>
+                </a:solidFill>
+                <a:latin typeface="メイリオ"/>
+                <a:ea typeface="メイリオ"/>
+                <a:cs typeface="メイリオ"/>
+              </a:rPr>
+              <a:t>1.5% 増し</a:t>
             </a:r>
           </a:p>
           <a:p>
@@ -30631,7 +30601,29 @@
                 <a:ea typeface="メイリオ"/>
                 <a:cs typeface="メイリオ"/>
               </a:rPr>
-              <a:t>1SD あたり 1.06% 増し</a:t>
+              <a:t>1 標準偏差あたり</a:t>
+            </a:r>
+            <a:endParaRPr lang="ja-JP" sz="1000" b="0" dirty="0">
+              <a:solidFill>
+                <a:srgbClr val="7E7F7E"/>
+              </a:solidFill>
+              <a:latin typeface="メイリオ"/>
+              <a:ea typeface="メイリオ"/>
+              <a:cs typeface="メイリオ"/>
+            </a:endParaRPr>
+          </a:p>
+          <a:p>
+            <a:pPr algn="ctr"/>
+            <a:r>
+              <a:rPr lang="ja-JP" sz="1000" b="0">
+                <a:solidFill>
+                  <a:srgbClr val="7E7F7E"/>
+                </a:solidFill>
+                <a:latin typeface="メイリオ"/>
+                <a:ea typeface="メイリオ"/>
+                <a:cs typeface="メイリオ"/>
+              </a:rPr>
+              <a:t>1.06% 増し</a:t>
             </a:r>
             <a:endParaRPr lang="ja-JP" sz="1000" b="0" dirty="0">
               <a:solidFill>

</xml_diff>